<commit_message>
Editing copy re-synced to the 48-slide build with the new contents slide
Co-Authored-By: Claude Fable 5.1 <noreply@anthropic.com>
</commit_message>
<xml_diff>
--- a/demo_session/deck_gauges_baseline.pptx
+++ b/demo_session/deck_gauges_baseline.pptx
@@ -6459,7 +6459,7 @@
                 </a:solidFill>
                 <a:latin typeface="Arial"/>
               </a:rPr>
-              <a:t>•  3-8 The jobs; the bench and its parts</a:t>
+              <a:t>•  3 Introduction: the three jobs and how they are scored</a:t>
             </a:r>
           </a:p>
           <a:p>
@@ -6475,7 +6475,7 @@
                 </a:solidFill>
                 <a:latin typeface="Arial"/>
               </a:rPr>
-              <a:t>•  9-19 The four approaches: interferometer, Zernike, vector Zernike, pinhole</a:t>
+              <a:t>•  4 The bench layout</a:t>
             </a:r>
           </a:p>
           <a:p>
@@ -6491,7 +6491,7 @@
                 </a:solidFill>
                 <a:latin typeface="Arial"/>
               </a:rPr>
-              <a:t>•  20-25 Performance on the working surface: rows, capture, photons, servo</a:t>
+              <a:t>•  6 Parts</a:t>
             </a:r>
           </a:p>
           <a:p>
@@ -6507,7 +6507,71 @@
                 </a:solidFill>
                 <a:latin typeface="Arial"/>
               </a:rPr>
-              <a:t>•  26-28 Lenses or off-axis mirrors</a:t>
+              <a:t>•  9 Twyman-Green interferometer</a:t>
+            </a:r>
+          </a:p>
+          <a:p>
+            <a:pPr>
+              <a:spcAft>
+                <a:spcPts val="600"/>
+              </a:spcAft>
+            </a:pPr>
+            <a:r>
+              <a:rPr sz="1200" b="0">
+                <a:solidFill>
+                  <a:srgbClr val="282828"/>
+                </a:solidFill>
+                <a:latin typeface="Arial"/>
+              </a:rPr>
+              <a:t>•  12 Zernike sensor</a:t>
+            </a:r>
+          </a:p>
+          <a:p>
+            <a:pPr>
+              <a:spcAft>
+                <a:spcPts val="600"/>
+              </a:spcAft>
+            </a:pPr>
+            <a:r>
+              <a:rPr sz="1200" b="0">
+                <a:solidFill>
+                  <a:srgbClr val="282828"/>
+                </a:solidFill>
+                <a:latin typeface="Arial"/>
+              </a:rPr>
+              <a:t>•  14 Vector Zernike sensor</a:t>
+            </a:r>
+          </a:p>
+          <a:p>
+            <a:pPr>
+              <a:spcAft>
+                <a:spcPts val="600"/>
+              </a:spcAft>
+            </a:pPr>
+            <a:r>
+              <a:rPr sz="1200" b="0">
+                <a:solidFill>
+                  <a:srgbClr val="282828"/>
+                </a:solidFill>
+                <a:latin typeface="Arial"/>
+              </a:rPr>
+              <a:t>•  17 Point-diffraction sensor</a:t>
+            </a:r>
+          </a:p>
+          <a:p>
+            <a:pPr>
+              <a:spcAft>
+                <a:spcPts val="600"/>
+              </a:spcAft>
+            </a:pPr>
+            <a:r>
+              <a:rPr sz="1200" b="0">
+                <a:solidFill>
+                  <a:srgbClr val="282828"/>
+                </a:solidFill>
+                <a:latin typeface="Arial"/>
+              </a:rPr>
+              <a:t>•  20 Performance: rows, capture, photons, servo</a:t>
             </a:r>
           </a:p>
         </p:txBody>
@@ -6546,7 +6610,7 @@
                 </a:solidFill>
                 <a:latin typeface="Arial"/>
               </a:rPr>
-              <a:t>•  29-30 Systematics; recommendation</a:t>
+              <a:t>•  26 Lenses versus off-axis parabolas</a:t>
             </a:r>
           </a:p>
           <a:p>
@@ -6562,7 +6626,7 @@
                 </a:solidFill>
                 <a:latin typeface="Arial"/>
               </a:rPr>
-              <a:t>•  31-33 Operating the gauge</a:t>
+              <a:t>•  27 The reflective front end and its performance</a:t>
             </a:r>
           </a:p>
           <a:p>
@@ -6578,7 +6642,7 @@
                 </a:solidFill>
                 <a:latin typeface="Arial"/>
               </a:rPr>
-              <a:t>•  34-36 Future work</a:t>
+              <a:t>•  29 Comparison and recommendation</a:t>
             </a:r>
           </a:p>
           <a:p>
@@ -6594,7 +6658,7 @@
                 </a:solidFill>
                 <a:latin typeface="Arial"/>
               </a:rPr>
-              <a:t>•  37-38 Method; run it yourself</a:t>
+              <a:t>•  32 Complex amplitude</a:t>
             </a:r>
           </a:p>
           <a:p>
@@ -6610,7 +6674,39 @@
                 </a:solidFill>
                 <a:latin typeface="Arial"/>
               </a:rPr>
-              <a:t>•  39-48 Backup</a:t>
+              <a:t>•  33 Summary and future work</a:t>
+            </a:r>
+          </a:p>
+          <a:p>
+            <a:pPr>
+              <a:spcAft>
+                <a:spcPts val="600"/>
+              </a:spcAft>
+            </a:pPr>
+            <a:r>
+              <a:rPr sz="1200" b="0">
+                <a:solidFill>
+                  <a:srgbClr val="282828"/>
+                </a:solidFill>
+                <a:latin typeface="Arial"/>
+              </a:rPr>
+              <a:t>•  38 Run it yourself</a:t>
+            </a:r>
+          </a:p>
+          <a:p>
+            <a:pPr>
+              <a:spcAft>
+                <a:spcPts val="600"/>
+              </a:spcAft>
+            </a:pPr>
+            <a:r>
+              <a:rPr sz="1200" b="0">
+                <a:solidFill>
+                  <a:srgbClr val="282828"/>
+                </a:solidFill>
+                <a:latin typeface="Arial"/>
+              </a:rPr>
+              <a:t>•  39 Backup</a:t>
             </a:r>
           </a:p>
         </p:txBody>

</xml_diff>

<commit_message>
Deck: edit copy and baseline synced from the build (slides 12-15 pass)
Co-Authored-By: Claude Opus 5 (1M context) <noreply@anthropic.com>
</commit_message>
<xml_diff>
--- a/demo_session/deck_gauges_baseline.pptx
+++ b/demo_session/deck_gauges_baseline.pptx
@@ -4040,7 +4040,7 @@
                 </a:solidFill>
                 <a:latin typeface="Arial"/>
               </a:rPr>
-              <a:t>The key signals along the train for the flat mirror and for the 30 nm working surface, on the redesigned mirror rig: the absolute map is within 2% of the engine's field, the differential rows within 2.4 pm</a:t>
+              <a:t>The key signals along the train for the flat mirror and for the 30 nm working surface, on the redesigned mirror rig: the absolute map is within 1.5% of the engine's field, the differential rows within 1.8 pm</a:t>
             </a:r>
           </a:p>
         </p:txBody>
@@ -4091,7 +4091,7 @@
       </p:sp>
       <p:pic>
         <p:nvPicPr>
-          <p:cNvPr id="4" name="Picture 3" descr="stnoap_stations.png"/>
+          <p:cNvPr id="4" name="Picture 3" descr="redo96_oapstn_stations.png"/>
           <p:cNvPicPr>
             <a:picLocks noChangeAspect="1"/>
           </p:cNvPicPr>
@@ -4105,8 +4105,8 @@
         </p:blipFill>
         <p:spPr>
           <a:xfrm>
-            <a:off x="2026767" y="1298448"/>
-            <a:ext cx="8138160" cy="2531872"/>
+            <a:off x="2028583" y="1298448"/>
+            <a:ext cx="8134528" cy="2531872"/>
           </a:xfrm>
           <a:prstGeom prst="rect">
             <a:avLst/>
@@ -4186,7 +4186,7 @@
                 </a:solidFill>
                 <a:latin typeface="Arial"/>
               </a:rPr>
-              <a:t>•  The residual column is the absolute read against the engine: 0.00 pm on the flat, 626 pm on the 30 nm surface (2% of the figure); the differential rows the servo uses read the same surface's changes to 2.4 pm, which is why the matrix is measured on the surface.</a:t>
+              <a:t>•  The residual column is the absolute read against the engine: 0.00 pm on the flat, 463 pm on the 30 nm surface (1.5% of the figure); the differential rows the servo uses read the same surface's changes to 1.8 pm, which is why the matrix is measured on the surface.</a:t>
             </a:r>
           </a:p>
         </p:txBody>
@@ -4225,7 +4225,7 @@
                 </a:solidFill>
                 <a:latin typeface="Arial"/>
               </a:rPr>
-              <a:t>Run tag stnoap (the redesigned mirror rig, seed detector leg; bit-identical to the servo run's figure).  The lens rig's figure exists but its residual panel reads 62 nm against the engine, a misregistration under investigation, so it is not shown.</a:t>
+              <a:t>Run tag redo96_oapstn (the mirror rig on the redo bench, Mac cycle 3c, 2026-09-18).  The lens rig's figure exists but its residual panel reads 51 nm against the engine — a fold, not the pupil-image bowl the earlier hypothesis blamed: the bowl is gone and the residual barely moved (62 → 51 nm).  Under investigation, so it is not shown.</a:t>
             </a:r>
           </a:p>
         </p:txBody>
@@ -4298,7 +4298,7 @@
                 </a:solidFill>
                 <a:latin typeface="Arial"/>
               </a:rPr>
-              <a:t>The camera sees the DM sharply on both front ends; against a single global mapping the image is distorted by a third of a pitch at the edge on lenses and most of a pitch on mirrors, which the measured response matrix absorbs and a geometric mapping would not</a:t>
+              <a:t>The camera sees the DM sharply on both front ends; against a single global mapping the image is distorted by a seventh of a pitch at the edge on lenses and more than a pitch on mirrors, which the measured response matrix absorbs and a geometric mapping would not</a:t>
             </a:r>
           </a:p>
         </p:txBody>
@@ -4349,7 +4349,7 @@
       </p:sp>
       <p:pic>
         <p:nvPicPr>
-          <p:cNvPr id="4" name="Picture 3" descr="pupilq_lens_pupil.png"/>
+          <p:cNvPr id="4" name="Picture 3" descr="pupilq96_lens_pupil.png"/>
           <p:cNvPicPr>
             <a:picLocks noChangeAspect="1"/>
           </p:cNvPicPr>
@@ -4421,7 +4421,7 @@
         </p:nvGraphicFramePr>
         <p:xfrm>
           <a:off x="6400800" y="1298448"/>
-          <a:ext cx="5394958" cy="1314450"/>
+          <a:ext cx="5394958" cy="1657350"/>
         </p:xfrm>
         <a:graphic>
           <a:graphicData uri="http://schemas.openxmlformats.org/drawingml/2006/table">
@@ -4430,9 +4430,9 @@
                 <a:tableStyleId>{5C22544A-7EE6-4342-B048-85BDC9FD1C3A}</a:tableStyleId>
               </a:tblPr>
               <a:tblGrid>
-                <a:gridCol w="3159202"/>
-                <a:gridCol w="1098853"/>
-                <a:gridCol w="1136903"/>
+                <a:gridCol w="2873402"/>
+                <a:gridCol w="1407380"/>
+                <a:gridCol w="1114176"/>
               </a:tblGrid>
               <a:tr h="262890">
                 <a:tc>
@@ -4537,7 +4537,7 @@
                           </a:solidFill>
                           <a:latin typeface="Arial"/>
                         </a:rPr>
-                        <a:t>0.13 / 0.30</a:t>
+                        <a:t>0.047 / 0.138</a:t>
                       </a:r>
                     </a:p>
                   </a:txBody>
@@ -4559,7 +4559,7 @@
                           </a:solidFill>
                           <a:latin typeface="Arial"/>
                         </a:rPr>
-                        <a:t>0.45 / 0.85</a:t>
+                        <a:t>0.62 / 1.19</a:t>
                       </a:r>
                     </a:p>
                   </a:txBody>
@@ -4605,7 +4605,7 @@
                           </a:solidFill>
                           <a:latin typeface="Arial"/>
                         </a:rPr>
-                        <a:t>0.023 / 0.060</a:t>
+                        <a:t>0.066 / 0.133</a:t>
                       </a:r>
                     </a:p>
                   </a:txBody>
@@ -4627,7 +4627,7 @@
                           </a:solidFill>
                           <a:latin typeface="Arial"/>
                         </a:rPr>
-                        <a:t>0.032 / 0.093</a:t>
+                        <a:t>0.051 / 0.143</a:t>
                       </a:r>
                     </a:p>
                   </a:txBody>
@@ -4638,7 +4638,7 @@
                   </a:tcPr>
                 </a:tc>
               </a:tr>
-              <a:tr h="262890">
+              <a:tr h="434340">
                 <a:tc>
                   <a:txBody>
                     <a:bodyPr wrap="square"/>
@@ -4651,7 +4651,7 @@
                           </a:solidFill>
                           <a:latin typeface="Arial"/>
                         </a:rPr>
-                        <a:t>image surface: defocus / tilt (mm of sag)</a:t>
+                        <a:t>image surface: defocus / astig / tilt (mm of sag)</a:t>
                       </a:r>
                     </a:p>
                   </a:txBody>
@@ -4673,7 +4673,7 @@
                           </a:solidFill>
                           <a:latin typeface="Arial"/>
                         </a:rPr>
-                        <a:t>3.8 / 0.0</a:t>
+                        <a:t>-0.0005 / -0.095 / 0.002</a:t>
                       </a:r>
                     </a:p>
                   </a:txBody>
@@ -4695,7 +4695,7 @@
                           </a:solidFill>
                           <a:latin typeface="Arial"/>
                         </a:rPr>
-                        <a:t>-0.5 / 0.45</a:t>
+                        <a:t>-0.45 / 0.14 / 0.42</a:t>
                       </a:r>
                     </a:p>
                   </a:txBody>
@@ -4706,7 +4706,7 @@
                   </a:tcPr>
                 </a:tc>
               </a:tr>
-              <a:tr h="262890">
+              <a:tr h="434340">
                 <a:tc>
                   <a:txBody>
                     <a:bodyPr wrap="square"/>
@@ -4741,7 +4741,7 @@
                           </a:solidFill>
                           <a:latin typeface="Arial"/>
                         </a:rPr>
-                        <a:t>0.16 / 0.16 λF/D</a:t>
+                        <a:t>0.06 / 0.09 λF/D</a:t>
                       </a:r>
                     </a:p>
                   </a:txBody>
@@ -4763,7 +4763,7 @@
                           </a:solidFill>
                           <a:latin typeface="Arial"/>
                         </a:rPr>
-                        <a:t>0.00 / 2.3 λF/D</a:t>
+                        <a:t>0.03 / 2.2 λF/D</a:t>
                       </a:r>
                     </a:p>
                   </a:txBody>
@@ -4786,7 +4786,7 @@
         </p:nvSpPr>
         <p:spPr>
           <a:xfrm>
-            <a:off x="6400800" y="2759202"/>
+            <a:off x="6400800" y="3102102"/>
             <a:ext cx="5394960" cy="274320"/>
           </a:xfrm>
           <a:prstGeom prst="rect">
@@ -4812,7 +4812,7 @@
                 </a:solidFill>
                 <a:latin typeface="Arial"/>
               </a:rPr>
-              <a:t>•  Method: the DM declared the stop; the field a tilt about it (a spatial frequency on its surface); two traces a small field step apart cross at each zone's image at the camera; scored in DM millimeters against the 1 mm pitch and the 0.4 mm pixel.</a:t>
+              <a:t>•  Method: the DM declared the stop, the field a tilt about it; two traces a small field step apart cross at each zone's image at the camera; scored in DM mm against the 1 mm pitch.</a:t>
             </a:r>
           </a:p>
           <a:p>
@@ -4828,7 +4828,23 @@
                 </a:solidFill>
                 <a:latin typeface="Arial"/>
               </a:rPr>
-              <a:t>•  The mirror rig's focus is perfect on axis and coma-limited off it (2.3 λF/D at the actuator-band tilt); not a pupil-image or mask-sensor cost, a number to know for any off-axis reading at the seat.</a:t>
+              <a:t>•  What package A did here: the lens rig's image went flat (0.5 µm of defocus against 3.8 mm) and its distortion fell 2.8×; the mirror rig's went the other way (edge 0.85 → 1.19 mm), the OAP pair's mapping, and why the distortion gate was withdrawn.</a:t>
+            </a:r>
+          </a:p>
+          <a:p>
+            <a:pPr>
+              <a:spcAft>
+                <a:spcPts val="600"/>
+              </a:spcAft>
+            </a:pPr>
+            <a:r>
+              <a:rPr sz="1400" b="0">
+                <a:solidFill>
+                  <a:srgbClr val="282828"/>
+                </a:solidFill>
+                <a:latin typeface="Arial"/>
+              </a:rPr>
+              <a:t>•  The mirror rig's focus is perfect on axis and coma-limited off it (2.2 λF/D at the actuator-band tilt); not a pupil-image cost, a number to know for any off-axis reading at the seat.</a:t>
             </a:r>
           </a:p>
         </p:txBody>
@@ -4841,7 +4857,7 @@
         </p:nvSpPr>
         <p:spPr>
           <a:xfrm>
-            <a:off x="6400800" y="5184648"/>
+            <a:off x="6400800" y="6332982"/>
             <a:ext cx="5394960" cy="274320"/>
           </a:xfrm>
           <a:prstGeom prst="rect">
@@ -4867,7 +4883,7 @@
                 </a:solidFill>
                 <a:latin typeface="Arial"/>
               </a:rPr>
-              <a:t>Run tags pupilq_lens, pupilq_oap (tg96_pupilq, model 512); tg_psi_dm96_oap/REPORT_bench_realism.md section 6.  Requested by Fang Shi.</a:t>
+              <a:t>Run tags pupilq96_lens, pupilq96_oap (tg96_pupilq, model 512, on the emitted redo decks, 2026-09-18); tg_psi_dm96_oap/REPORT_bench_realism.md section 6.  Requested by Fang Shi.  λF/D = 2.83 µm on the 96 mm beam.  Blur grew on both rigs against the record because the beam now fills the DM: it lit 77 / 82 mm of 96, leaving the edge zones, where the walk is largest, out of that average.</a:t>
             </a:r>
           </a:p>
         </p:txBody>
@@ -5183,7 +5199,7 @@
                 </a:solidFill>
                 <a:latin typeface="Arial"/>
               </a:rPr>
-              <a:t>The leg's point-spread function, zone by zone from the rays, applied to the DM's field and read out as the interferometer reads: every mode is observable; the lens rig's camera is not at the pupil image, and 4 mm fixes it</a:t>
+              <a:t>The leg's point-spread function, zone by zone from the rays, applied to the DM's field and read out as the interferometer reads: every mode is observable, and on the redo bench the camera sits AT the pupil image on both rigs — the detector move the record needed is gone</a:t>
             </a:r>
           </a:p>
         </p:txBody>
@@ -5234,7 +5250,7 @@
       </p:sp>
       <p:pic>
         <p:nvPicPr>
-          <p:cNvPr id="4" name="Picture 3" descr="pupilsim_lens_gain.png"/>
+          <p:cNvPr id="4" name="Picture 3" descr="pupilsim_redo_lens_gain.png"/>
           <p:cNvPicPr>
             <a:picLocks noChangeAspect="1"/>
           </p:cNvPicPr>
@@ -5306,7 +5322,7 @@
         </p:nvGraphicFramePr>
         <p:xfrm>
           <a:off x="7086600" y="1298448"/>
-          <a:ext cx="4709159" cy="1223010"/>
+          <a:ext cx="4709159" cy="1394460"/>
         </p:xfrm>
         <a:graphic>
           <a:graphicData uri="http://schemas.openxmlformats.org/drawingml/2006/table">
@@ -5315,11 +5331,11 @@
                 <a:tableStyleId>{5C22544A-7EE6-4342-B048-85BDC9FD1C3A}</a:tableStyleId>
               </a:tblPr>
               <a:tblGrid>
-                <a:gridCol w="2045023"/>
+                <a:gridCol w="2147731"/>
                 <a:gridCol w="542544"/>
-                <a:gridCol w="476504"/>
-                <a:gridCol w="476504"/>
-                <a:gridCol w="1168584"/>
+                <a:gridCol w="542544"/>
+                <a:gridCol w="542544"/>
+                <a:gridCol w="933796"/>
               </a:tblGrid>
               <a:tr h="434340">
                 <a:tc>
@@ -5446,7 +5462,7 @@
                           </a:solidFill>
                           <a:latin typeface="Arial"/>
                         </a:rPr>
-                        <a:t>lens rig, camera as built</a:t>
+                        <a:t>lens rig, redo bench</a:t>
                       </a:r>
                     </a:p>
                   </a:txBody>
@@ -5468,7 +5484,7 @@
                           </a:solidFill>
                           <a:latin typeface="Arial"/>
                         </a:rPr>
-                        <a:t>0.990</a:t>
+                        <a:t>1.0000</a:t>
                       </a:r>
                     </a:p>
                   </a:txBody>
@@ -5490,7 +5506,7 @@
                           </a:solidFill>
                           <a:latin typeface="Arial"/>
                         </a:rPr>
-                        <a:t>0.973</a:t>
+                        <a:t>1.0000</a:t>
                       </a:r>
                     </a:p>
                   </a:txBody>
@@ -5512,7 +5528,7 @@
                           </a:solidFill>
                           <a:latin typeface="Arial"/>
                         </a:rPr>
-                        <a:t>0.954</a:t>
+                        <a:t>1.0000</a:t>
                       </a:r>
                     </a:p>
                   </a:txBody>
@@ -5534,7 +5550,7 @@
                           </a:solidFill>
                           <a:latin typeface="Arial"/>
                         </a:rPr>
-                        <a:t>1.2 nm</a:t>
+                        <a:t>42 pm</a:t>
                       </a:r>
                     </a:p>
                   </a:txBody>
@@ -5558,7 +5574,7 @@
                           </a:solidFill>
                           <a:latin typeface="Arial"/>
                         </a:rPr>
-                        <a:t>lens rig, camera +4.3 mm</a:t>
+                        <a:t>mirror rig, redo bench</a:t>
                       </a:r>
                     </a:p>
                   </a:txBody>
@@ -5580,7 +5596,7 @@
                           </a:solidFill>
                           <a:latin typeface="Arial"/>
                         </a:rPr>
-                        <a:t>0.997</a:t>
+                        <a:t>0.9994</a:t>
                       </a:r>
                     </a:p>
                   </a:txBody>
@@ -5602,7 +5618,7 @@
                           </a:solidFill>
                           <a:latin typeface="Arial"/>
                         </a:rPr>
-                        <a:t>0.998</a:t>
+                        <a:t>0.9994</a:t>
                       </a:r>
                     </a:p>
                   </a:txBody>
@@ -5624,7 +5640,7 @@
                           </a:solidFill>
                           <a:latin typeface="Arial"/>
                         </a:rPr>
-                        <a:t>0.993</a:t>
+                        <a:t>0.9994</a:t>
                       </a:r>
                     </a:p>
                   </a:txBody>
@@ -5646,7 +5662,7 @@
                           </a:solidFill>
                           <a:latin typeface="Arial"/>
                         </a:rPr>
-                        <a:t>0.4 nm</a:t>
+                        <a:t>92 pm</a:t>
                       </a:r>
                     </a:p>
                   </a:txBody>
@@ -5657,7 +5673,7 @@
                   </a:tcPr>
                 </a:tc>
               </a:tr>
-              <a:tr h="262890">
+              <a:tr h="434340">
                 <a:tc>
                   <a:txBody>
                     <a:bodyPr wrap="square"/>
@@ -5670,7 +5686,7 @@
                           </a:solidFill>
                           <a:latin typeface="Arial"/>
                         </a:rPr>
-                        <a:t>mirror rig, as built</a:t>
+                        <a:t>lens rig, the record's tuned tail (superseded)</a:t>
                       </a:r>
                     </a:p>
                   </a:txBody>
@@ -5692,7 +5708,7 @@
                           </a:solidFill>
                           <a:latin typeface="Arial"/>
                         </a:rPr>
-                        <a:t>1.000</a:t>
+                        <a:t>0.990</a:t>
                       </a:r>
                     </a:p>
                   </a:txBody>
@@ -5714,7 +5730,7 @@
                           </a:solidFill>
                           <a:latin typeface="Arial"/>
                         </a:rPr>
-                        <a:t>0.999</a:t>
+                        <a:t>0.973</a:t>
                       </a:r>
                     </a:p>
                   </a:txBody>
@@ -5736,7 +5752,7 @@
                           </a:solidFill>
                           <a:latin typeface="Arial"/>
                         </a:rPr>
-                        <a:t>0.997</a:t>
+                        <a:t>0.954</a:t>
                       </a:r>
                     </a:p>
                   </a:txBody>
@@ -5758,7 +5774,7 @@
                           </a:solidFill>
                           <a:latin typeface="Arial"/>
                         </a:rPr>
-                        <a:t>0.2 nm</a:t>
+                        <a:t>1.2 nm</a:t>
                       </a:r>
                     </a:p>
                   </a:txBody>
@@ -5823,7 +5839,7 @@
                 </a:solidFill>
                 <a:latin typeface="Arial"/>
               </a:rPr>
-              <a:t>•  The image is a bowl the camera sits ahead of on the lens rig: 2.6 mm on axis, 6 mm at the edge (the tail was tuned on the flat-mirror null, which cannot see pupil defocus).  The mirror rig's thin-lens seat is within 1.3 mm of its image.</a:t>
+              <a:t>•  The bowl is gone.  On the record's tuned tail the image was a surface the camera sat 2.6 mm ahead of on axis and 6 at the edge, because that tail was tuned on the flat-mirror null, which cannot see pupil defocus.  On the redo bench the best detector move is −0.00 mm: there is nothing left to correct, and the band-edge phase is 0.000 rad rms on lenses, 0.013 on mirrors.</a:t>
             </a:r>
           </a:p>
           <a:p>
@@ -5852,8 +5868,8 @@
         </p:nvSpPr>
         <p:spPr>
           <a:xfrm>
-            <a:off x="7086600" y="5330952"/>
-            <a:ext cx="4709160" cy="274320"/>
+            <a:off x="6400800" y="5611622"/>
+            <a:ext cx="5394960" cy="274320"/>
           </a:xfrm>
           <a:prstGeom prst="rect">
             <a:avLst/>
@@ -5878,7 +5894,7 @@
                 </a:solidFill>
                 <a:latin typeface="Arial"/>
               </a:rPr>
-              <a:t>Run tags pupilsim_lens, pupilsim_oap (tg96_pupilsim; run it yourself: tg96_pupil_batch.sh both); REPORT_bench_realism.md section 7.  The engine's own plane-to-plane check through reference surfaces is built and needs the station-to-station form (in progress).</a:t>
+              <a:t>Run tags pupilsim_redo_lens, pupilsim_redo_oap (tg96_pupilsim on the emitted redo decks = package A's gate record, 2026-09-17; run it yourself: tg96_pupil_batch.sh both).  The superseded row is the record's tuned tail, kept so the gain is legible; REPORT_bench_realism.md section 7.  The engine's own plane-to-plane check through reference surfaces is built and needs the station-to-station form (in progress).</a:t>
             </a:r>
           </a:p>
         </p:txBody>
@@ -17879,8 +17895,8 @@
         </p:blipFill>
         <p:spPr>
           <a:xfrm>
-            <a:off x="2012287" y="1298448"/>
-            <a:ext cx="2604825" cy="2384552"/>
+            <a:off x="1143000" y="1554480"/>
+            <a:ext cx="4343400" cy="3931920"/>
           </a:xfrm>
           <a:prstGeom prst="rect">
             <a:avLst/>
@@ -17895,8 +17911,8 @@
         </p:nvSpPr>
         <p:spPr>
           <a:xfrm>
-            <a:off x="411480" y="3701287"/>
-            <a:ext cx="5806440" cy="724408"/>
+            <a:off x="411480" y="5696712"/>
+            <a:ext cx="4343400" cy="1054608"/>
           </a:xfrm>
           <a:prstGeom prst="rect">
             <a:avLst/>

</xml_diff>